<commit_message>
Working version, but have a better way of computing the data so will rework on the FormatData.py and Calculation.py
</commit_message>
<xml_diff>
--- a/ArcticSBI_Results_DefengLu.pptx
+++ b/ArcticSBI_Results_DefengLu.pptx
@@ -115,6 +115,11 @@
       </a:defRPr>
     </a:lvl9pPr>
   </p:defaultTextStyle>
+  <p:extLst>
+    <p:ext uri="{EFAFB233-063F-42B5-8137-9DF3F51BA10A}">
+      <p15:sldGuideLst xmlns:p15="http://schemas.microsoft.com/office/powerpoint/2012/main"/>
+    </p:ext>
+  </p:extLst>
 </p:presentation>
 </file>
 
@@ -200,7 +205,7 @@
           <a:p>
             <a:fld id="{6A700887-73D3-47B6-BB14-4A78EBBE82D6}" type="datetimeFigureOut">
               <a:rPr lang="en-US" smtClean="0"/>
-              <a:t>7/30/2026</a:t>
+              <a:t>7/31/2026</a:t>
             </a:fld>
             <a:endParaRPr lang="en-US"/>
           </a:p>
@@ -620,7 +625,7 @@
           <a:p>
             <a:fld id="{C128FA71-3A18-48C0-980F-4B68F7F63042}" type="datetime1">
               <a:rPr lang="en-US" smtClean="0"/>
-              <a:t>7/30/2026</a:t>
+              <a:t>7/31/2026</a:t>
             </a:fld>
             <a:endParaRPr lang="en-US"/>
           </a:p>
@@ -828,7 +833,7 @@
           <a:p>
             <a:fld id="{7104EDB3-C0E8-45F8-9E1D-1B6C8D1880C0}" type="datetime1">
               <a:rPr lang="en-US" smtClean="0"/>
-              <a:t>7/30/2026</a:t>
+              <a:t>7/31/2026</a:t>
             </a:fld>
             <a:endParaRPr lang="en-US"/>
           </a:p>
@@ -1038,7 +1043,7 @@
           <a:p>
             <a:fld id="{9CF0EC4B-54ED-4041-B552-9BA760FA3DBA}" type="datetime1">
               <a:rPr lang="en-US" smtClean="0"/>
-              <a:t>7/30/2026</a:t>
+              <a:t>7/31/2026</a:t>
             </a:fld>
             <a:endParaRPr lang="en-US"/>
           </a:p>
@@ -1236,7 +1241,7 @@
           <a:p>
             <a:fld id="{51C1210E-201E-4473-82AC-2466F5386C38}" type="datetime1">
               <a:rPr lang="en-US" smtClean="0"/>
-              <a:t>7/30/2026</a:t>
+              <a:t>7/31/2026</a:t>
             </a:fld>
             <a:endParaRPr lang="en-US"/>
           </a:p>
@@ -1514,7 +1519,7 @@
           <a:p>
             <a:fld id="{B01EA198-6CAB-4B8F-B93F-1F9C8C4B6CE7}" type="datetime1">
               <a:rPr lang="en-US" smtClean="0"/>
-              <a:t>7/30/2026</a:t>
+              <a:t>7/31/2026</a:t>
             </a:fld>
             <a:endParaRPr lang="en-US"/>
           </a:p>
@@ -1786,7 +1791,7 @@
           <a:p>
             <a:fld id="{CA06041F-4525-44D5-AA4F-332294BF1F56}" type="datetime1">
               <a:rPr lang="en-US" smtClean="0"/>
-              <a:t>7/30/2026</a:t>
+              <a:t>7/31/2026</a:t>
             </a:fld>
             <a:endParaRPr lang="en-US"/>
           </a:p>
@@ -2210,7 +2215,7 @@
           <a:p>
             <a:fld id="{F9557091-BBDF-4EB9-BA6B-2BB67AC4FC0F}" type="datetime1">
               <a:rPr lang="en-US" smtClean="0"/>
-              <a:t>7/30/2026</a:t>
+              <a:t>7/31/2026</a:t>
             </a:fld>
             <a:endParaRPr lang="en-US"/>
           </a:p>
@@ -2351,7 +2356,7 @@
           <a:p>
             <a:fld id="{2D6B226B-77A6-410C-9796-083F278E0125}" type="datetime1">
               <a:rPr lang="en-US" smtClean="0"/>
-              <a:t>7/30/2026</a:t>
+              <a:t>7/31/2026</a:t>
             </a:fld>
             <a:endParaRPr lang="en-US"/>
           </a:p>
@@ -2464,7 +2469,7 @@
           <a:p>
             <a:fld id="{A23A578B-D289-4C40-8593-3D356C49DA58}" type="datetime1">
               <a:rPr lang="en-US" smtClean="0"/>
-              <a:t>7/30/2026</a:t>
+              <a:t>7/31/2026</a:t>
             </a:fld>
             <a:endParaRPr lang="en-US"/>
           </a:p>
@@ -2783,7 +2788,7 @@
           <a:p>
             <a:fld id="{713DFAE3-14DB-48A7-A80F-80DDB072CE3D}" type="datetime1">
               <a:rPr lang="en-US" smtClean="0"/>
-              <a:t>7/30/2026</a:t>
+              <a:t>7/31/2026</a:t>
             </a:fld>
             <a:endParaRPr lang="en-US"/>
           </a:p>
@@ -3077,7 +3082,7 @@
           <a:p>
             <a:fld id="{92C5EAEF-6478-4102-8F5D-A5FE9FC97ACB}" type="datetime1">
               <a:rPr lang="en-US" smtClean="0"/>
-              <a:t>7/30/2026</a:t>
+              <a:t>7/31/2026</a:t>
             </a:fld>
             <a:endParaRPr lang="en-US"/>
           </a:p>
@@ -3318,7 +3323,7 @@
           <a:p>
             <a:fld id="{67F45AC6-C491-4585-A584-9CE2AF7D5500}" type="datetime1">
               <a:rPr lang="en-US" smtClean="0"/>
-              <a:t>7/30/2026</a:t>
+              <a:t>7/31/2026</a:t>
             </a:fld>
             <a:endParaRPr lang="en-US"/>
           </a:p>
@@ -6203,8 +6208,52 @@
           <a:p>
             <a:r>
               <a:rPr lang="en-US" dirty="0"/>
-              <a:t>If time allows, look into CMIP5 models to try to explain the results</a:t>
-            </a:r>
+              <a:t>If time allows, look into CMIP6 models to try to explain the results</a:t>
+            </a:r>
+          </a:p>
+          <a:p>
+            <a:endParaRPr lang="en-US" dirty="0"/>
+          </a:p>
+          <a:p>
+            <a:r>
+              <a:rPr lang="en-US" dirty="0"/>
+              <a:t>Temperature profile per pressure: avg temp at each pressure levels</a:t>
+            </a:r>
+          </a:p>
+          <a:p>
+            <a:r>
+              <a:rPr lang="en-US" dirty="0"/>
+              <a:t>Could average per month </a:t>
+            </a:r>
+            <a:r>
+              <a:rPr lang="en-US" dirty="0">
+                <a:sym typeface="Wingdings" panose="05000000000000000000" pitchFamily="2" charset="2"/>
+              </a:rPr>
+              <a:t> 00UTC and 12UTC together for better idea of monthly average</a:t>
+            </a:r>
+          </a:p>
+          <a:p>
+            <a:pPr marL="228600" lvl="1" indent="0">
+              <a:buNone/>
+            </a:pPr>
+            <a:r>
+              <a:rPr lang="en-US" dirty="0">
+                <a:sym typeface="Wingdings" panose="05000000000000000000" pitchFamily="2" charset="2"/>
+              </a:rPr>
+              <a:t>So that we go from 6-&gt; graphs, can also do mean for </a:t>
+            </a:r>
+            <a:r>
+              <a:rPr lang="en-US">
+                <a:sym typeface="Wingdings" panose="05000000000000000000" pitchFamily="2" charset="2"/>
+              </a:rPr>
+              <a:t>winter months</a:t>
+            </a:r>
+          </a:p>
+          <a:p>
+            <a:pPr marL="228600" lvl="1" indent="0">
+              <a:buNone/>
+            </a:pPr>
+            <a:endParaRPr lang="en-US" dirty="0"/>
           </a:p>
         </p:txBody>
       </p:sp>

</xml_diff>